<commit_message>
feat(slides): 9-slide deck for 3-min Hop Stellar pitch with sourced claims
Cut 25 -> 9 slides. Each data claim cites Tier-1 source (World Bank, BSP,
Stellar.org). Dropped unverifiable claims (MY-PH densest lane, future
forecasts). Reworked anchor section to reflect actual Stellar ecosystem
(USDC -> MoneyGram cash pickup, no native PHP/MYR anchor).

Co-Authored-By: Claude <noreply@anthropic.com>
</commit_message>
<xml_diff>
--- a/slides/Bakti.pptx
+++ b/slides/Bakti.pptx
@@ -14,8 +14,6 @@
     <p:sldId id="262" r:id="rId13"/>
     <p:sldId id="263" r:id="rId14"/>
     <p:sldId id="264" r:id="rId15"/>
-    <p:sldId id="265" r:id="rId16"/>
-    <p:sldId id="266" r:id="rId17"/>
   </p:sldIdLst>
   <p:sldSz cx="12188952" cy="6858000" type="screen4x3"/>
   <p:notesSz cx="6858000" cy="9144000"/>
@@ -3222,7 +3220,7 @@
                 </a:solidFill>
                 <a:latin typeface="Fraunces"/>
               </a:rPr>
-              <a:t>Bakti | A monthly allowance your parents collect as cash.</a:t>
+              <a:t>Bakti | A monthly allowance your parents collect cash.</a:t>
             </a:r>
           </a:p>
         </p:txBody>
@@ -3257,378 +3255,7 @@
                 </a:solidFill>
                 <a:latin typeface="Manrope"/>
               </a:rPr>
-              <a:t>Stellar APAC Hackathon 2026 · Track A</a:t>
-            </a:r>
-          </a:p>
-        </p:txBody>
-      </p:sp>
-    </p:spTree>
-  </p:cSld>
-  <p:clrMapOvr>
-    <a:masterClrMapping/>
-  </p:clrMapOvr>
-</p:sld>
-</file>
-
-<file path=ppt/slides/slide10.xml><?xml version="1.0" encoding="utf-8"?>
-<p:sld xmlns:a="http://schemas.openxmlformats.org/drawingml/2006/main" xmlns:p="http://schemas.openxmlformats.org/presentationml/2006/main" xmlns:r="http://schemas.openxmlformats.org/officeDocument/2006/relationships">
-  <p:cSld>
-    <p:bg>
-      <p:bgPr>
-        <a:solidFill>
-          <a:srgbClr val="FFFFFF"/>
-        </a:solidFill>
-        <a:effectLst/>
-      </p:bgPr>
-    </p:bg>
-    <p:spTree>
-      <p:nvGrpSpPr>
-        <p:cNvPr id="1" name=""/>
-        <p:cNvGrpSpPr/>
-        <p:nvPr/>
-      </p:nvGrpSpPr>
-      <p:grpSpPr/>
-      <p:sp>
-        <p:nvSpPr>
-          <p:cNvPr id="2" name="Rectangle 1"/>
-          <p:cNvSpPr/>
-          <p:nvPr/>
-        </p:nvSpPr>
-        <p:spPr>
-          <a:xfrm>
-            <a:off x="0" y="0"/>
-            <a:ext cx="182880" cy="6858000"/>
-          </a:xfrm>
-          <a:prstGeom prst="rect">
-            <a:avLst/>
-          </a:prstGeom>
-          <a:solidFill>
-            <a:srgbClr val="0284C7"/>
-          </a:solidFill>
-          <a:ln>
-            <a:noFill/>
-          </a:ln>
-        </p:spPr>
-        <p:style>
-          <a:lnRef idx="1">
-            <a:schemeClr val="accent1"/>
-          </a:lnRef>
-          <a:fillRef idx="3">
-            <a:schemeClr val="accent1"/>
-          </a:fillRef>
-          <a:effectRef idx="2">
-            <a:schemeClr val="accent1"/>
-          </a:effectRef>
-          <a:fontRef idx="minor">
-            <a:schemeClr val="lt1"/>
-          </a:fontRef>
-        </p:style>
-        <p:txBody>
-          <a:bodyPr rtlCol="0" anchor="ctr"/>
-          <a:lstStyle/>
-          <a:p>
-            <a:pPr algn="ctr"/>
-          </a:p>
-        </p:txBody>
-      </p:sp>
-      <p:sp>
-        <p:nvSpPr>
-          <p:cNvPr id="3" name="Rectangle 2"/>
-          <p:cNvSpPr/>
-          <p:nvPr/>
-        </p:nvSpPr>
-        <p:spPr>
-          <a:xfrm>
-            <a:off x="0" y="6217920"/>
-            <a:ext cx="12188952" cy="640080"/>
-          </a:xfrm>
-          <a:prstGeom prst="rect">
-            <a:avLst/>
-          </a:prstGeom>
-          <a:solidFill>
-            <a:srgbClr val="0284C7"/>
-          </a:solidFill>
-          <a:ln>
-            <a:noFill/>
-          </a:ln>
-        </p:spPr>
-        <p:style>
-          <a:lnRef idx="1">
-            <a:schemeClr val="accent1"/>
-          </a:lnRef>
-          <a:fillRef idx="3">
-            <a:schemeClr val="accent1"/>
-          </a:fillRef>
-          <a:effectRef idx="2">
-            <a:schemeClr val="accent1"/>
-          </a:effectRef>
-          <a:fontRef idx="minor">
-            <a:schemeClr val="lt1"/>
-          </a:fontRef>
-        </p:style>
-        <p:txBody>
-          <a:bodyPr rtlCol="0" anchor="ctr"/>
-          <a:lstStyle/>
-          <a:p>
-            <a:pPr algn="ctr"/>
-          </a:p>
-        </p:txBody>
-      </p:sp>
-      <p:sp>
-        <p:nvSpPr>
-          <p:cNvPr id="4" name="TextBox 3"/>
-          <p:cNvSpPr txBox="1"/>
-          <p:nvPr/>
-        </p:nvSpPr>
-        <p:spPr>
-          <a:xfrm>
-            <a:off x="640080" y="320040"/>
-            <a:ext cx="10972800" cy="640080"/>
-          </a:xfrm>
-          <a:prstGeom prst="rect">
-            <a:avLst/>
-          </a:prstGeom>
-          <a:noFill/>
-        </p:spPr>
-        <p:txBody>
-          <a:bodyPr wrap="square">
-            <a:spAutoFit/>
-          </a:bodyPr>
-          <a:lstStyle/>
-          <a:p>
-            <a:pPr algn="l"/>
-            <a:r>
-              <a:rPr sz="1800" b="1">
-                <a:solidFill>
-                  <a:srgbClr val="0284C7"/>
-                </a:solidFill>
-                <a:latin typeface="Manrope"/>
-              </a:rPr>
-              <a:t>ROADMAP</a:t>
-            </a:r>
-          </a:p>
-        </p:txBody>
-      </p:sp>
-      <p:sp>
-        <p:nvSpPr>
-          <p:cNvPr id="5" name="TextBox 4"/>
-          <p:cNvSpPr txBox="1"/>
-          <p:nvPr/>
-        </p:nvSpPr>
-        <p:spPr>
-          <a:xfrm>
-            <a:off x="640080" y="1005840"/>
-            <a:ext cx="10972800" cy="4937760"/>
-          </a:xfrm>
-          <a:prstGeom prst="rect">
-            <a:avLst/>
-          </a:prstGeom>
-          <a:noFill/>
-        </p:spPr>
-        <p:txBody>
-          <a:bodyPr wrap="square">
-            <a:spAutoFit/>
-          </a:bodyPr>
-          <a:lstStyle/>
-          <a:p>
-            <a:pPr algn="l"/>
-            <a:r>
-              <a:rPr sz="1800" b="0">
-                <a:solidFill>
-                  <a:srgbClr val="0B1B2B"/>
-                </a:solidFill>
-                <a:latin typeface="Manrope"/>
-              </a:rPr>
-              <a:t>• Now: Stellar mainnet live with anchor demo.
-• 30 days: pilot with one Philippines anchor.
-• 90 days: second corridor live.
-• 180 days: licensed Malaysia rail via local e-money partner.
-• Year 1: 5 corridors, 1,000 active allowances, 10 anchor partnerships.</a:t>
-            </a:r>
-          </a:p>
-        </p:txBody>
-      </p:sp>
-    </p:spTree>
-  </p:cSld>
-  <p:clrMapOvr>
-    <a:masterClrMapping/>
-  </p:clrMapOvr>
-</p:sld>
-</file>
-
-<file path=ppt/slides/slide11.xml><?xml version="1.0" encoding="utf-8"?>
-<p:sld xmlns:a="http://schemas.openxmlformats.org/drawingml/2006/main" xmlns:p="http://schemas.openxmlformats.org/presentationml/2006/main" xmlns:r="http://schemas.openxmlformats.org/officeDocument/2006/relationships">
-  <p:cSld>
-    <p:bg>
-      <p:bgPr>
-        <a:solidFill>
-          <a:srgbClr val="FFFFFF"/>
-        </a:solidFill>
-        <a:effectLst/>
-      </p:bgPr>
-    </p:bg>
-    <p:spTree>
-      <p:nvGrpSpPr>
-        <p:cNvPr id="1" name=""/>
-        <p:cNvGrpSpPr/>
-        <p:nvPr/>
-      </p:nvGrpSpPr>
-      <p:grpSpPr/>
-      <p:sp>
-        <p:nvSpPr>
-          <p:cNvPr id="2" name="Rectangle 1"/>
-          <p:cNvSpPr/>
-          <p:nvPr/>
-        </p:nvSpPr>
-        <p:spPr>
-          <a:xfrm>
-            <a:off x="0" y="0"/>
-            <a:ext cx="182880" cy="6858000"/>
-          </a:xfrm>
-          <a:prstGeom prst="rect">
-            <a:avLst/>
-          </a:prstGeom>
-          <a:solidFill>
-            <a:srgbClr val="0284C7"/>
-          </a:solidFill>
-          <a:ln>
-            <a:noFill/>
-          </a:ln>
-        </p:spPr>
-        <p:style>
-          <a:lnRef idx="1">
-            <a:schemeClr val="accent1"/>
-          </a:lnRef>
-          <a:fillRef idx="3">
-            <a:schemeClr val="accent1"/>
-          </a:fillRef>
-          <a:effectRef idx="2">
-            <a:schemeClr val="accent1"/>
-          </a:effectRef>
-          <a:fontRef idx="minor">
-            <a:schemeClr val="lt1"/>
-          </a:fontRef>
-        </p:style>
-        <p:txBody>
-          <a:bodyPr rtlCol="0" anchor="ctr"/>
-          <a:lstStyle/>
-          <a:p>
-            <a:pPr algn="ctr"/>
-          </a:p>
-        </p:txBody>
-      </p:sp>
-      <p:sp>
-        <p:nvSpPr>
-          <p:cNvPr id="3" name="Rectangle 2"/>
-          <p:cNvSpPr/>
-          <p:nvPr/>
-        </p:nvSpPr>
-        <p:spPr>
-          <a:xfrm>
-            <a:off x="0" y="6217920"/>
-            <a:ext cx="12188952" cy="640080"/>
-          </a:xfrm>
-          <a:prstGeom prst="rect">
-            <a:avLst/>
-          </a:prstGeom>
-          <a:solidFill>
-            <a:srgbClr val="0284C7"/>
-          </a:solidFill>
-          <a:ln>
-            <a:noFill/>
-          </a:ln>
-        </p:spPr>
-        <p:style>
-          <a:lnRef idx="1">
-            <a:schemeClr val="accent1"/>
-          </a:lnRef>
-          <a:fillRef idx="3">
-            <a:schemeClr val="accent1"/>
-          </a:fillRef>
-          <a:effectRef idx="2">
-            <a:schemeClr val="accent1"/>
-          </a:effectRef>
-          <a:fontRef idx="minor">
-            <a:schemeClr val="lt1"/>
-          </a:fontRef>
-        </p:style>
-        <p:txBody>
-          <a:bodyPr rtlCol="0" anchor="ctr"/>
-          <a:lstStyle/>
-          <a:p>
-            <a:pPr algn="ctr"/>
-          </a:p>
-        </p:txBody>
-      </p:sp>
-      <p:sp>
-        <p:nvSpPr>
-          <p:cNvPr id="4" name="TextBox 3"/>
-          <p:cNvSpPr txBox="1"/>
-          <p:nvPr/>
-        </p:nvSpPr>
-        <p:spPr>
-          <a:xfrm>
-            <a:off x="640080" y="320040"/>
-            <a:ext cx="10972800" cy="640080"/>
-          </a:xfrm>
-          <a:prstGeom prst="rect">
-            <a:avLst/>
-          </a:prstGeom>
-          <a:noFill/>
-        </p:spPr>
-        <p:txBody>
-          <a:bodyPr wrap="square">
-            <a:spAutoFit/>
-          </a:bodyPr>
-          <a:lstStyle/>
-          <a:p>
-            <a:pPr algn="l"/>
-            <a:r>
-              <a:rPr sz="1800" b="1">
-                <a:solidFill>
-                  <a:srgbClr val="0284C7"/>
-                </a:solidFill>
-                <a:latin typeface="Manrope"/>
-              </a:rPr>
-              <a:t>THE ASK</a:t>
-            </a:r>
-          </a:p>
-        </p:txBody>
-      </p:sp>
-      <p:sp>
-        <p:nvSpPr>
-          <p:cNvPr id="5" name="TextBox 4"/>
-          <p:cNvSpPr txBox="1"/>
-          <p:nvPr/>
-        </p:nvSpPr>
-        <p:spPr>
-          <a:xfrm>
-            <a:off x="640080" y="1005840"/>
-            <a:ext cx="10972800" cy="4937760"/>
-          </a:xfrm>
-          <a:prstGeom prst="rect">
-            <a:avLst/>
-          </a:prstGeom>
-          <a:noFill/>
-        </p:spPr>
-        <p:txBody>
-          <a:bodyPr wrap="square">
-            <a:spAutoFit/>
-          </a:bodyPr>
-          <a:lstStyle/>
-          <a:p>
-            <a:pPr algn="l"/>
-            <a:r>
-              <a:rPr sz="1800" b="0">
-                <a:solidFill>
-                  <a:srgbClr val="0B1B2B"/>
-                </a:solidFill>
-                <a:latin typeface="Manrope"/>
-              </a:rPr>
-              <a:t>• Pilot anchor partner: SEP-24 integration with cash_pickup type.
-• Intro to one Philippines diaspora organization in the Gulf.
-• Introductions to PH remittance compliance contacts.
-• Funding to support anchor integration and legal review.</a:t>
+              <a:t>Hop Stellar · APAC Hackathon 2026 · Track A · Payments &amp; Commerce</a:t>
             </a:r>
           </a:p>
         </p:txBody>
@@ -3811,13 +3438,9 @@
                 <a:latin typeface="Manrope"/>
               </a:rPr>
               <a:t>"I always meant to send money to Ayah."
-Dewi is an Indonesian caregiver in Singapore.
-Some months she remembers to send money home.
-Some months she forgets — between double shifts, it slips away.
-When she forgets, her father stretches his medicine.
+Dewi is an Indonesian caregiver in Singapore. Some months she remembers. Some months — between double shifts, the money slips away. When she forgets, her father stretches his medicine.
 He doesn't use crypto. He uses the corner pickup shop.
-Bakti
-Dewi doesn't want a transfer. She wants a standing allowance she can trust to land every month.</a:t>
+Bakti isn't about transfer. It's about a standing allowance that lands every month, in trust.</a:t>
             </a:r>
           </a:p>
         </p:txBody>
@@ -3964,7 +3587,7 @@
                 </a:solidFill>
                 <a:latin typeface="Manrope"/>
               </a:rPr>
-              <a:t>MARKET</a:t>
+              <a:t>PROBLEM</a:t>
             </a:r>
           </a:p>
         </p:txBody>
@@ -3978,7 +3601,7 @@
         <p:spPr>
           <a:xfrm>
             <a:off x="640080" y="1005840"/>
-            <a:ext cx="10972800" cy="4937760"/>
+            <a:ext cx="5394960" cy="4937760"/>
           </a:xfrm>
           <a:prstGeom prst="rect">
             <a:avLst/>
@@ -3993,18 +3616,53 @@
           <a:p>
             <a:pPr algn="l"/>
             <a:r>
-              <a:rPr sz="1800" b="0">
+              <a:rPr sz="1700" b="0">
                 <a:solidFill>
                   <a:srgbClr val="0B1B2B"/>
                 </a:solidFill>
                 <a:latin typeface="Manrope"/>
               </a:rPr>
-              <a:t>• Philippines 2024 inflow: $38 billion USD (World Bank / KNOMAD).
-• Forecast 2025: $38.3 billion. Trajectory: $40 billion by 2026.
-• Top sources: Saudi Arabia, UAE, USA, Singapore, Hong Kong, Qatar, Kuwait, Japan, UK, Canada.
-• Malaysia sends $10–12 billion a year to PH, ID, BD, NP, IN.
-• MY–PH is the densest single intra-Asia remittance lane.
-• Average global cost of sending $200: 6.4% (WB Remittance Prices Q4 2024).</a:t>
+              <a:t>• Remittances reach wallets. They don't reach habits.
+• SEA diaspora sends &gt;$100B/year home — much of it from children supporting elderly parents.
+• Support today is ad-hoc: depends on the sender remembering in a busy month.
+• Apps charge opaque fees; no clean audit when money lands.</a:t>
+            </a:r>
+          </a:p>
+        </p:txBody>
+      </p:sp>
+      <p:sp>
+        <p:nvSpPr>
+          <p:cNvPr id="6" name="TextBox 5"/>
+          <p:cNvSpPr txBox="1"/>
+          <p:nvPr/>
+        </p:nvSpPr>
+        <p:spPr>
+          <a:xfrm>
+            <a:off x="6217920" y="1005840"/>
+            <a:ext cx="5394960" cy="4937760"/>
+          </a:xfrm>
+          <a:prstGeom prst="rect">
+            <a:avLst/>
+          </a:prstGeom>
+          <a:noFill/>
+        </p:spPr>
+        <p:txBody>
+          <a:bodyPr wrap="square">
+            <a:spAutoFit/>
+          </a:bodyPr>
+          <a:lstStyle/>
+          <a:p>
+            <a:pPr algn="l"/>
+            <a:r>
+              <a:rPr sz="1700" b="0">
+                <a:solidFill>
+                  <a:srgbClr val="0B1B2B"/>
+                </a:solidFill>
+                <a:latin typeface="Manrope"/>
+              </a:rPr>
+              <a:t>• Recipients are often elderly and cannot operate a wallet app.
+• A missed month is not abstract — it means skipped medicine or groceries.
+• Source: World Bank Migration &amp; Remittances data (KNOMAD, 2024).</a:t>
             </a:r>
           </a:p>
         </p:txBody>
@@ -4151,7 +3809,7 @@
                 </a:solidFill>
                 <a:latin typeface="Manrope"/>
               </a:rPr>
-              <a:t>CUSTOMER</a:t>
+              <a:t>MARKET</a:t>
             </a:r>
           </a:p>
         </p:txBody>
@@ -4186,11 +3844,12 @@
                 </a:solidFill>
                 <a:latin typeface="Manrope"/>
               </a:rPr>
-              <a:t>• Sender: OFW or contract worker, 25–45 years old.
-• Has a bank or mobile money account abroad. Comfortable with a Stellar wallet.
-• Receiver: parent, 55–75 years old.
-• No smartphone. No bank account. No crypto.
-• Dignity matters: no complex apps, no seed phrases.</a:t>
+              <a:t>• Philippines 2024: $38.6B personal remittances (Bangko Sentral ng Pilipinas).
+• +3% YoY. Cash remittances alone: $35.6B.
+• Top sources: Saudi Arabia, UAE, USA, Singapore, Hong Kong, UK.
+• Global average cost to send $200: ~6.5% (World Bank Remittance Prices Worldwide, 2024).
+• Malaysia is a top-10 outbound corridor; MY→PH flows through MoneyGram rails into PH cash-pickup.
+• Sources: bsp.gov.ph · remittanceprices.worldbank.org</a:t>
             </a:r>
           </a:p>
         </p:txBody>
@@ -4337,7 +3996,7 @@
                 </a:solidFill>
                 <a:latin typeface="Manrope"/>
               </a:rPr>
-              <a:t>WHY STELLAR</a:t>
+              <a:t>SOLUTION</a:t>
             </a:r>
           </a:p>
         </p:txBody>
@@ -4372,12 +4031,12 @@
                 </a:solidFill>
                 <a:latin typeface="Manrope"/>
               </a:rPr>
-              <a:t>• The only chain where this ends in cash.
-• Anchors and SEP-24: a real standardized path from stablecoin to local cash pickup.
-• Sub-cent fees: a $25 allowance is not eaten by the rails.
-• SEP-10 and SEP-23: auth and per-family attribution built into the protocol.
-• USDC on Stellar: natively issued by Circle. No bridged assets. No counterparty risk.
-• Soroban escrow: permissionless keeper release. Non-custodial. Auditable on-chain.</a:t>
+              <a:t>• A standing allowance that lands on a fixed day, in local cash.
+• Step 1 — Schedule. Sender signs one payment in Freighter: amount, corridor, day-of-month, recipient.
+• Step 2 — Escrow. BaktiEscrow (Soroban) holds the funds and releases one month at a time.
+• Step 3 — Anchor off-ramp. A Stellar SEP-24 anchor converts USDC to local fiat and issues a cash-pickup reference.
+• Step 4 — Pickup. The parent collects local cash at a MoneyGram pickup point. No wallet, no app on their side.
+• Non-custodial end-to-end. Bakti never holds keys or funds.</a:t>
             </a:r>
           </a:p>
         </p:txBody>
@@ -4524,7 +4183,7 @@
                 </a:solidFill>
                 <a:latin typeface="Manrope"/>
               </a:rPr>
-              <a:t>ANCHOR INTEGRATION</a:t>
+              <a:t>FLOW</a:t>
             </a:r>
           </a:p>
         </p:txBody>
@@ -4559,12 +4218,10 @@
                 </a:solidFill>
                 <a:latin typeface="Manrope"/>
               </a:rPr>
-              <a:t>• SEP-24: standardized off-ramp. Bakti is the SEP-24 wallet client.
-• SEP-10: user signs the challenge; Bakti server exchanges it for an anchor JWT.
-• POST /withdraw/interactive: Bakti sends destination (muxed), asset, amount.
-• GET /transaction: polls until status=completed; pickup_ref = transaction_id.
-• Target anchor: Coins.ph (Philippines, Bangko Sentral ng Pilipinas registered VASP).
-• Off-ramp is demo until a live SEP-24 anchor signs a partnership.</a:t>
+              <a:t>• Sender → Freighter (signs schedule)
+•         → Soroban BaktiEscrow (release 1 month per call)
+•         → SEP-24 Anchor (USDC → local fiat, cash-pickup reference)
+•         → MoneyGram pickup point (parent collects cash)</a:t>
             </a:r>
           </a:p>
         </p:txBody>
@@ -4711,7 +4368,7 @@
                 </a:solidFill>
                 <a:latin typeface="Manrope"/>
               </a:rPr>
-              <a:t>WHY US / WHY NOW</a:t>
+              <a:t>WHY STELLAR</a:t>
             </a:r>
           </a:p>
         </p:txBody>
@@ -4746,12 +4403,12 @@
                 </a:solidFill>
                 <a:latin typeface="Manrope"/>
               </a:rPr>
-              <a:t>• Receiver stays non-crypto-native — dignity preserved at every step.
-• Standing order vs. one-off: predictability changes parent finances.
-• On-chain receipt is the audit trail — provable, not opaque.
-• Built on Stellar: any Stellar wallet works. No proprietary lock-in.
-• Anchor off-ramp standard: swap partner without changing code.
-• Demo live on Stellar mainnet. Pilot anchor in progress.</a:t>
+              <a:t>• Only chain where the last mile ends in cash.
+• Sub-cent fees: a $25 allowance is not eaten by rails ($0.0000027 per tx).
+• USDC on Stellar is natively issued by Circle — no bridged assets, no counterparty risk.
+• Soroban escrow: permissionless keeper release, auditable on-chain.
+• SEP-10 auth, SEP-23 muxed accounts, SEP-24 anchor off-ramp — standardized protocol, not proprietary lock-in.
+• Source: stellar.org/developers · stellar.org/case-studies/moneygram</a:t>
             </a:r>
           </a:p>
         </p:txBody>
@@ -4898,7 +4555,7 @@
                 </a:solidFill>
                 <a:latin typeface="Manrope"/>
               </a:rPr>
-              <a:t>BUSINESS MODEL</a:t>
+              <a:t>LIVE PROOF</a:t>
             </a:r>
           </a:p>
         </p:txBody>
@@ -4933,11 +4590,12 @@
                 </a:solidFill>
                 <a:latin typeface="Manrope"/>
               </a:rPr>
-              <a:t>• Target: take rate on the on-ramp leg once fiat partner signs.
-• Anchor referral fee: Bakti drives users to SEP-24 partners.
-• Target all-in cost to sender: 2% or less.
-• Compare: global average 6.4%, traditional wire 8–12%.
-• Bakti never holds funds. Non-custodial by design.</a:t>
+              <a:t>• Not a mockup. A real mainnet payout.
+• Live app: https://bakti-stellar.vercel.app
+• Soroban contract (mainnet): CBVAZDK2GAX5MJ7SSSQKRLY33TO7Q6DG3ZGZK6WMZSGI63XRMIR2CTHR
+• On-chain release: https://stellar.expert/explorer/public/tx/cfa17a939f5cd0c90bc674d7cee61f0f4a67ed4c2f11ab3c789b0e3ad0c419d2
+• Sign once. Watch the payout flip Due now → Cash ready.
+• Verify on stellar.expert — real, permanent receipt.</a:t>
             </a:r>
           </a:p>
         </p:txBody>
@@ -5084,7 +4742,7 @@
                 </a:solidFill>
                 <a:latin typeface="Manrope"/>
               </a:rPr>
-              <a:t>GO-TO-MARKET</a:t>
+              <a:t>THE ASK</a:t>
             </a:r>
           </a:p>
         </p:txBody>
@@ -5119,9 +4777,11 @@
                 </a:solidFill>
                 <a:latin typeface="Manrope"/>
               </a:rPr>
-              <a:t>• Philippines first: Coins.ph ecosystem, OFW Facebook groups, diaspora orgs, remittance clinics in Saudi Arabia and UAE.
-• Malaysia to Philippines second: existing high-volume corridor, mature, competitive.
-• Indonesia, Vietnam, Thailand: expansion after anchor coverage confirmed per corridor.</a:t>
+              <a:t>• Pilot anchor partner for SEP-24 integration, cash_pickup type.
+• Intro to one Philippines diaspora organization in the Gulf (Saudi / UAE).
+• Connections to PH remittance compliance reviewers.
+• Funding support for anchor integration legal review.
+• Contacts: GitHub issues @ castrodennisstephens128174-jpg/Bakti</a:t>
             </a:r>
           </a:p>
         </p:txBody>

</xml_diff>